<commit_message>
feat: verify POI against official municipal lists
02b_official_poi.py собирает перечни школ и детсадов с obr-ku.ru, 02c_verify_poi.py чистит OSM от ложных объектов, сопоставляет по номеру, геокодирует недостающие через Nominatim и собирает poi_verified.gpkg. Расчёты переведены на сверенный слой: покрытие школ выросло с 67 до 75 %, школа №39 (Монастырка) вошла в топ критичных объектов.
</commit_message>
<xml_diff>
--- a/presentation.pptx
+++ b/presentation.pptx
@@ -3921,7 +3921,7 @@
                 </a:solidFill>
                 <a:latin typeface="Calibri"/>
               </a:rPr>
-              <a:t>•  36 школ, 64 детсада, 31 медучреждение</a:t>
+              <a:t>•  36 школ, 67 детсадов, 31 медучреждение</a:t>
             </a:r>
           </a:p>
           <a:p>
@@ -4376,7 +4376,7 @@
                 </a:solidFill>
                 <a:latin typeface="Calibri"/>
               </a:rPr>
-              <a:t>67 %</a:t>
+              <a:t>75 %</a:t>
             </a:r>
           </a:p>
         </p:txBody>
@@ -4418,7 +4418,7 @@
                 </a:solidFill>
                 <a:latin typeface="Calibri"/>
               </a:rPr>
-              <a:t>89 %</a:t>
+              <a:t>90 %</a:t>
             </a:r>
           </a:p>
         </p:txBody>
@@ -4712,7 +4712,7 @@
                 </a:solidFill>
                 <a:latin typeface="Calibri"/>
               </a:rPr>
-              <a:t>Одновременно 33–54 % жилья не имеет ни одного объекта в пределах 15 минут — избыточность и дефицит сосуществуют в разных частях города.</a:t>
+              <a:t>Одновременно 25–54 % жилья не имеет ни одного объекта в пределах 15 минут — избыточность и дефицит сосуществуют в разных частях города.</a:t>
             </a:r>
           </a:p>
         </p:txBody>
@@ -5217,7 +5217,7 @@
                 </a:solidFill>
                 <a:latin typeface="Calibri"/>
               </a:rPr>
-              <a:t>71 %</a:t>
+              <a:t>72 %</a:t>
             </a:r>
           </a:p>
         </p:txBody>
@@ -5259,7 +5259,7 @@
                 </a:solidFill>
                 <a:latin typeface="Calibri"/>
               </a:rPr>
-              <a:t>23 %</a:t>
+              <a:t>28 %</a:t>
             </a:r>
           </a:p>
         </p:txBody>
@@ -5301,7 +5301,7 @@
                 </a:solidFill>
                 <a:latin typeface="Calibri"/>
               </a:rPr>
-              <a:t>−48 п.п.</a:t>
+              <a:t>−43 п.п.</a:t>
             </a:r>
           </a:p>
         </p:txBody>
@@ -5950,7 +5950,7 @@
                 </a:solidFill>
                 <a:latin typeface="Calibri"/>
               </a:rPr>
-              <a:t>•  Умеренный (0 %): −12 школ, −32 детсада, −10 поликлиник при неизменном покрытии</a:t>
+              <a:t>•  Умеренный (0 %): −12 школ, −33 детсада, −10 поликлиник при неизменном покрытии</a:t>
             </a:r>
           </a:p>
           <a:p>
@@ -5969,7 +5969,7 @@
                 </a:solidFill>
                 <a:latin typeface="Calibri"/>
               </a:rPr>
-              <a:t>•  Средний (1 %): −18 школ, −15 поликлиник, потеря 0,4–0,8 п.п.</a:t>
+              <a:t>•  Средний (1 %): −17 школ, −15 поликлиник, потеря 0,4–0,6 п.п.</a:t>
             </a:r>
           </a:p>
           <a:p>
@@ -6007,7 +6007,7 @@
                 </a:solidFill>
                 <a:latin typeface="Calibri"/>
               </a:rPr>
-              <a:t>•  Критичные объекты: Школа №32 (10,9 % жилья), Детсад №34 (7,7 %)</a:t>
+              <a:t>•  Критичные объекты: Школа №32 (10,9 % жилья), Школа №39 (7,7 %), Детсад №34 (7,7 %)</a:t>
             </a:r>
           </a:p>
           <a:p>
@@ -6336,7 +6336,7 @@
                 </a:solidFill>
                 <a:latin typeface="Calibri"/>
               </a:rPr>
-              <a:t>•  Сверка объектов с перечнями obr-ku.ru и miacso.ru</a:t>
+              <a:t>•  Сверка медицинских учреждений по перечню МИАЦ</a:t>
             </a:r>
           </a:p>
           <a:p>

</xml_diff>